<commit_message>
Add mobile previews for compact presentation
Co-authored-by: vaslarinmelnikova-hash <vaslarinmelnikova-hash@users.noreply.github.com>
</commit_message>
<xml_diff>
--- a/Militarisation_Arctique_Version_Courte.pptx
+++ b/Militarisation_Arctique_Version_Courte.pptx
@@ -4412,7 +4412,7 @@
         </p:nvSpPr>
         <p:spPr>
           <a:xfrm>
-            <a:off x="8732520" y="6473952"/>
+            <a:off x="8732520" y="6327648"/>
             <a:ext cx="2907792" cy="164592"/>
           </a:xfrm>
           <a:prstGeom prst="rect">
@@ -5621,7 +5621,7 @@
         </p:nvSpPr>
         <p:spPr>
           <a:xfrm>
-            <a:off x="8732520" y="6473952"/>
+            <a:off x="8732520" y="6327648"/>
             <a:ext cx="2907792" cy="164592"/>
           </a:xfrm>
           <a:prstGeom prst="rect">
@@ -9250,7 +9250,7 @@
               </a:lnSpc>
             </a:pPr>
             <a:r>
-              <a:rPr sz="1300" b="1">
+              <a:rPr sz="1400" b="1">
                 <a:solidFill>
                   <a:srgbClr val="F4F8FB"/>
                 </a:solidFill>
@@ -9372,7 +9372,7 @@
               </a:lnSpc>
             </a:pPr>
             <a:r>
-              <a:rPr sz="1300" b="1">
+              <a:rPr sz="1400" b="1">
                 <a:solidFill>
                   <a:srgbClr val="F4F8FB"/>
                 </a:solidFill>
@@ -9494,7 +9494,7 @@
               </a:lnSpc>
             </a:pPr>
             <a:r>
-              <a:rPr sz="1300" b="1">
+              <a:rPr sz="1400" b="1">
                 <a:solidFill>
                   <a:srgbClr val="F4F8FB"/>
                 </a:solidFill>
@@ -9553,7 +9553,7 @@
         </p:nvSpPr>
         <p:spPr>
           <a:xfrm>
-            <a:off x="8732520" y="6473952"/>
+            <a:off x="8732520" y="6327648"/>
             <a:ext cx="2907792" cy="164592"/>
           </a:xfrm>
           <a:prstGeom prst="rect">

</xml_diff>